<commit_message>
Introduction is updated, lit review started, ignore large CSV files
</commit_message>
<xml_diff>
--- a/Concept design report/Week 9 - Progress Meeting.pptx
+++ b/Concept design report/Week 9 - Progress Meeting.pptx
@@ -7,9 +7,6 @@
   <p:sldIdLst>
     <p:sldId id="256" r:id="rId2"/>
     <p:sldId id="257" r:id="rId3"/>
-    <p:sldId id="258" r:id="rId4"/>
-    <p:sldId id="259" r:id="rId5"/>
-    <p:sldId id="260" r:id="rId6"/>
   </p:sldIdLst>
   <p:sldSz cx="12192000" cy="6858000"/>
   <p:notesSz cx="6858000" cy="9144000"/>
@@ -116,12 +113,93 @@
 </p:presentation>
 </file>
 
-<file path=ppt/revisionInfo.xml><?xml version="1.0" encoding="utf-8"?>
-<p1510:revInfo xmlns:a="http://schemas.openxmlformats.org/drawingml/2006/main" xmlns:r="http://schemas.openxmlformats.org/officeDocument/2006/relationships" xmlns:p1510="http://schemas.microsoft.com/office/powerpoint/2015/10/main">
-  <p1510:revLst>
-    <p1510:client id="{FF3CC4A9-8EE0-49E8-A866-7B6525DDA8BD}" v="37" dt="2026-04-21T13:22:09.427"/>
-  </p1510:revLst>
-</p1510:revInfo>
+<file path=ppt/changesInfos/changesInfo1.xml><?xml version="1.0" encoding="utf-8"?>
+<pc:chgInfo xmlns:a="http://schemas.openxmlformats.org/drawingml/2006/main" xmlns:r="http://schemas.openxmlformats.org/officeDocument/2006/relationships" xmlns:ac="http://schemas.microsoft.com/office/drawing/2013/main/command" xmlns:pc="http://schemas.microsoft.com/office/powerpoint/2013/main/command">
+  <pc:docChgLst>
+    <pc:chgData name="Matota, LN, Miss [24989142@sun.ac.za]" userId="7a1f7bb1-56ac-4c00-937c-47b0bcb81363" providerId="ADAL" clId="{8B03531C-D65D-4FC7-A92A-A0BB20D20D7C}"/>
+    <pc:docChg chg="undo custSel addSld delSld modSld">
+      <pc:chgData name="Matota, LN, Miss [24989142@sun.ac.za]" userId="7a1f7bb1-56ac-4c00-937c-47b0bcb81363" providerId="ADAL" clId="{8B03531C-D65D-4FC7-A92A-A0BB20D20D7C}" dt="2026-08-18T12:05:31.475" v="701" actId="20577"/>
+      <pc:docMkLst>
+        <pc:docMk/>
+      </pc:docMkLst>
+      <pc:sldChg chg="modSp mod">
+        <pc:chgData name="Matota, LN, Miss [24989142@sun.ac.za]" userId="7a1f7bb1-56ac-4c00-937c-47b0bcb81363" providerId="ADAL" clId="{8B03531C-D65D-4FC7-A92A-A0BB20D20D7C}" dt="2026-08-18T09:42:11.326" v="177" actId="20577"/>
+        <pc:sldMkLst>
+          <pc:docMk/>
+          <pc:sldMk cId="3634458474" sldId="256"/>
+        </pc:sldMkLst>
+        <pc:spChg chg="mod">
+          <ac:chgData name="Matota, LN, Miss [24989142@sun.ac.za]" userId="7a1f7bb1-56ac-4c00-937c-47b0bcb81363" providerId="ADAL" clId="{8B03531C-D65D-4FC7-A92A-A0BB20D20D7C}" dt="2026-08-18T09:38:40.108" v="8" actId="20577"/>
+          <ac:spMkLst>
+            <pc:docMk/>
+            <pc:sldMk cId="3634458474" sldId="256"/>
+            <ac:spMk id="4" creationId="{BB1F2019-93C2-EC76-597C-181B917B613F}"/>
+          </ac:spMkLst>
+        </pc:spChg>
+        <pc:spChg chg="mod">
+          <ac:chgData name="Matota, LN, Miss [24989142@sun.ac.za]" userId="7a1f7bb1-56ac-4c00-937c-47b0bcb81363" providerId="ADAL" clId="{8B03531C-D65D-4FC7-A92A-A0BB20D20D7C}" dt="2026-08-18T09:42:11.326" v="177" actId="20577"/>
+          <ac:spMkLst>
+            <pc:docMk/>
+            <pc:sldMk cId="3634458474" sldId="256"/>
+            <ac:spMk id="5" creationId="{1F8DBEAB-31A9-BA81-AEEB-213E0520AE5B}"/>
+          </ac:spMkLst>
+        </pc:spChg>
+      </pc:sldChg>
+      <pc:sldChg chg="addSp delSp modSp mod">
+        <pc:chgData name="Matota, LN, Miss [24989142@sun.ac.za]" userId="7a1f7bb1-56ac-4c00-937c-47b0bcb81363" providerId="ADAL" clId="{8B03531C-D65D-4FC7-A92A-A0BB20D20D7C}" dt="2026-08-18T12:05:31.475" v="701" actId="20577"/>
+        <pc:sldMkLst>
+          <pc:docMk/>
+          <pc:sldMk cId="1867381965" sldId="257"/>
+        </pc:sldMkLst>
+        <pc:spChg chg="add del mod">
+          <ac:chgData name="Matota, LN, Miss [24989142@sun.ac.za]" userId="7a1f7bb1-56ac-4c00-937c-47b0bcb81363" providerId="ADAL" clId="{8B03531C-D65D-4FC7-A92A-A0BB20D20D7C}" dt="2026-08-18T09:44:10.653" v="216" actId="20577"/>
+          <ac:spMkLst>
+            <pc:docMk/>
+            <pc:sldMk cId="1867381965" sldId="257"/>
+            <ac:spMk id="2" creationId="{3C821951-7634-C2E0-937D-C950C8DDAED8}"/>
+          </ac:spMkLst>
+        </pc:spChg>
+        <pc:spChg chg="add mod">
+          <ac:chgData name="Matota, LN, Miss [24989142@sun.ac.za]" userId="7a1f7bb1-56ac-4c00-937c-47b0bcb81363" providerId="ADAL" clId="{8B03531C-D65D-4FC7-A92A-A0BB20D20D7C}" dt="2026-08-18T12:05:31.475" v="701" actId="20577"/>
+          <ac:spMkLst>
+            <pc:docMk/>
+            <pc:sldMk cId="1867381965" sldId="257"/>
+            <ac:spMk id="3" creationId="{2476CFE0-1662-7E01-214A-32E6B228B22E}"/>
+          </ac:spMkLst>
+        </pc:spChg>
+        <pc:picChg chg="add del">
+          <ac:chgData name="Matota, LN, Miss [24989142@sun.ac.za]" userId="7a1f7bb1-56ac-4c00-937c-47b0bcb81363" providerId="ADAL" clId="{8B03531C-D65D-4FC7-A92A-A0BB20D20D7C}" dt="2026-08-18T09:43:06.574" v="184" actId="478"/>
+          <ac:picMkLst>
+            <pc:docMk/>
+            <pc:sldMk cId="1867381965" sldId="257"/>
+            <ac:picMk id="4" creationId="{6596B266-A043-3B8B-1A13-E73E984341FC}"/>
+          </ac:picMkLst>
+        </pc:picChg>
+      </pc:sldChg>
+      <pc:sldChg chg="add del">
+        <pc:chgData name="Matota, LN, Miss [24989142@sun.ac.za]" userId="7a1f7bb1-56ac-4c00-937c-47b0bcb81363" providerId="ADAL" clId="{8B03531C-D65D-4FC7-A92A-A0BB20D20D7C}" dt="2026-08-18T09:43:52.088" v="190" actId="47"/>
+        <pc:sldMkLst>
+          <pc:docMk/>
+          <pc:sldMk cId="3061533499" sldId="258"/>
+        </pc:sldMkLst>
+      </pc:sldChg>
+      <pc:sldChg chg="add del">
+        <pc:chgData name="Matota, LN, Miss [24989142@sun.ac.za]" userId="7a1f7bb1-56ac-4c00-937c-47b0bcb81363" providerId="ADAL" clId="{8B03531C-D65D-4FC7-A92A-A0BB20D20D7C}" dt="2026-08-18T09:43:52.088" v="190" actId="47"/>
+        <pc:sldMkLst>
+          <pc:docMk/>
+          <pc:sldMk cId="3534100090" sldId="259"/>
+        </pc:sldMkLst>
+      </pc:sldChg>
+      <pc:sldChg chg="add del">
+        <pc:chgData name="Matota, LN, Miss [24989142@sun.ac.za]" userId="7a1f7bb1-56ac-4c00-937c-47b0bcb81363" providerId="ADAL" clId="{8B03531C-D65D-4FC7-A92A-A0BB20D20D7C}" dt="2026-08-18T09:43:52.088" v="190" actId="47"/>
+        <pc:sldMkLst>
+          <pc:docMk/>
+          <pc:sldMk cId="4190784417" sldId="260"/>
+        </pc:sldMkLst>
+      </pc:sldChg>
+    </pc:docChg>
+  </pc:docChgLst>
+</pc:chgInfo>
 </file>
 
 <file path=ppt/slideLayouts/slideLayout1.xml><?xml version="1.0" encoding="utf-8"?>
@@ -273,7 +351,7 @@
           <a:p>
             <a:fld id="{B31332A8-CEAE-4241-9842-981792316C5A}" type="datetimeFigureOut">
               <a:rPr lang="en-ZA" smtClean="0"/>
-              <a:t>2026/04/21</a:t>
+              <a:t>2026/08/18</a:t>
             </a:fld>
             <a:endParaRPr lang="en-ZA"/>
           </a:p>
@@ -473,7 +551,7 @@
           <a:p>
             <a:fld id="{B31332A8-CEAE-4241-9842-981792316C5A}" type="datetimeFigureOut">
               <a:rPr lang="en-ZA" smtClean="0"/>
-              <a:t>2026/04/21</a:t>
+              <a:t>2026/08/18</a:t>
             </a:fld>
             <a:endParaRPr lang="en-ZA"/>
           </a:p>
@@ -683,7 +761,7 @@
           <a:p>
             <a:fld id="{B31332A8-CEAE-4241-9842-981792316C5A}" type="datetimeFigureOut">
               <a:rPr lang="en-ZA" smtClean="0"/>
-              <a:t>2026/04/21</a:t>
+              <a:t>2026/08/18</a:t>
             </a:fld>
             <a:endParaRPr lang="en-ZA"/>
           </a:p>
@@ -883,7 +961,7 @@
           <a:p>
             <a:fld id="{B31332A8-CEAE-4241-9842-981792316C5A}" type="datetimeFigureOut">
               <a:rPr lang="en-ZA" smtClean="0"/>
-              <a:t>2026/04/21</a:t>
+              <a:t>2026/08/18</a:t>
             </a:fld>
             <a:endParaRPr lang="en-ZA"/>
           </a:p>
@@ -1159,7 +1237,7 @@
           <a:p>
             <a:fld id="{B31332A8-CEAE-4241-9842-981792316C5A}" type="datetimeFigureOut">
               <a:rPr lang="en-ZA" smtClean="0"/>
-              <a:t>2026/04/21</a:t>
+              <a:t>2026/08/18</a:t>
             </a:fld>
             <a:endParaRPr lang="en-ZA"/>
           </a:p>
@@ -1427,7 +1505,7 @@
           <a:p>
             <a:fld id="{B31332A8-CEAE-4241-9842-981792316C5A}" type="datetimeFigureOut">
               <a:rPr lang="en-ZA" smtClean="0"/>
-              <a:t>2026/04/21</a:t>
+              <a:t>2026/08/18</a:t>
             </a:fld>
             <a:endParaRPr lang="en-ZA"/>
           </a:p>
@@ -1842,7 +1920,7 @@
           <a:p>
             <a:fld id="{B31332A8-CEAE-4241-9842-981792316C5A}" type="datetimeFigureOut">
               <a:rPr lang="en-ZA" smtClean="0"/>
-              <a:t>2026/04/21</a:t>
+              <a:t>2026/08/18</a:t>
             </a:fld>
             <a:endParaRPr lang="en-ZA"/>
           </a:p>
@@ -1984,7 +2062,7 @@
           <a:p>
             <a:fld id="{B31332A8-CEAE-4241-9842-981792316C5A}" type="datetimeFigureOut">
               <a:rPr lang="en-ZA" smtClean="0"/>
-              <a:t>2026/04/21</a:t>
+              <a:t>2026/08/18</a:t>
             </a:fld>
             <a:endParaRPr lang="en-ZA"/>
           </a:p>
@@ -2097,7 +2175,7 @@
           <a:p>
             <a:fld id="{B31332A8-CEAE-4241-9842-981792316C5A}" type="datetimeFigureOut">
               <a:rPr lang="en-ZA" smtClean="0"/>
-              <a:t>2026/04/21</a:t>
+              <a:t>2026/08/18</a:t>
             </a:fld>
             <a:endParaRPr lang="en-ZA"/>
           </a:p>
@@ -2410,7 +2488,7 @@
           <a:p>
             <a:fld id="{B31332A8-CEAE-4241-9842-981792316C5A}" type="datetimeFigureOut">
               <a:rPr lang="en-ZA" smtClean="0"/>
-              <a:t>2026/04/21</a:t>
+              <a:t>2026/08/18</a:t>
             </a:fld>
             <a:endParaRPr lang="en-ZA"/>
           </a:p>
@@ -2699,7 +2777,7 @@
           <a:p>
             <a:fld id="{B31332A8-CEAE-4241-9842-981792316C5A}" type="datetimeFigureOut">
               <a:rPr lang="en-ZA" smtClean="0"/>
-              <a:t>2026/04/21</a:t>
+              <a:t>2026/08/18</a:t>
             </a:fld>
             <a:endParaRPr lang="en-ZA"/>
           </a:p>
@@ -2942,7 +3020,7 @@
           <a:p>
             <a:fld id="{B31332A8-CEAE-4241-9842-981792316C5A}" type="datetimeFigureOut">
               <a:rPr lang="en-ZA" smtClean="0"/>
-              <a:t>2026/04/21</a:t>
+              <a:t>2026/08/18</a:t>
             </a:fld>
             <a:endParaRPr lang="en-ZA"/>
           </a:p>
@@ -3410,7 +3488,7 @@
                   <a:srgbClr val="C00000"/>
                 </a:solidFill>
               </a:rPr>
-              <a:t>Week 9 – Progress Meeting</a:t>
+              <a:t>Term 3 Week 5 – Progress Meeting</a:t>
             </a:r>
             <a:endParaRPr lang="en-ZA" sz="4000" dirty="0">
               <a:solidFill>
@@ -3466,7 +3544,7 @@
             </a:pPr>
             <a:r>
               <a:rPr lang="en-US" sz="2000" dirty="0"/>
-              <a:t>Concept generation</a:t>
+              <a:t>Report feedback</a:t>
             </a:r>
           </a:p>
           <a:p>
@@ -3476,13 +3554,8 @@
             </a:pPr>
             <a:r>
               <a:rPr lang="en-US" sz="2000" dirty="0"/>
-              <a:t>Derivation of D-H </a:t>
-            </a:r>
-            <a:r>
-              <a:rPr lang="en-US" sz="2000" dirty="0" err="1"/>
-              <a:t>parametrs</a:t>
-            </a:r>
-            <a:endParaRPr lang="en-US" sz="2000" dirty="0"/>
+              <a:t>Drawings hand-in</a:t>
+            </a:r>
           </a:p>
           <a:p>
             <a:pPr marL="342900" indent="-342900">
@@ -3491,7 +3564,7 @@
             </a:pPr>
             <a:r>
               <a:rPr lang="en-US" sz="2000" dirty="0"/>
-              <a:t>Derivation of D-H model</a:t>
+              <a:t>Safety report</a:t>
             </a:r>
           </a:p>
           <a:p>
@@ -3501,7 +3574,7 @@
             </a:pPr>
             <a:r>
               <a:rPr lang="en-US" sz="2000" dirty="0"/>
-              <a:t>Interpretation of results from D-H model</a:t>
+              <a:t>Software development</a:t>
             </a:r>
             <a:endParaRPr lang="en-ZA" sz="2000" dirty="0"/>
           </a:p>
@@ -3594,7 +3667,7 @@
                   <a:srgbClr val="C00000"/>
                 </a:solidFill>
               </a:rPr>
-              <a:t>Concept Generation</a:t>
+              <a:t>General Update</a:t>
             </a:r>
             <a:endParaRPr lang="en-ZA" sz="4000" dirty="0">
               <a:solidFill>
@@ -3604,108 +3677,22 @@
           </a:p>
         </p:txBody>
       </p:sp>
-      <p:pic>
-        <p:nvPicPr>
-          <p:cNvPr id="4" name="Picture 3">
-            <a:extLst>
-              <a:ext uri="{FF2B5EF4-FFF2-40B4-BE49-F238E27FC236}">
-                <a16:creationId xmlns:a16="http://schemas.microsoft.com/office/drawing/2014/main" id="{6596B266-A043-3B8B-1A13-E73E984341FC}"/>
-              </a:ext>
-            </a:extLst>
-          </p:cNvPr>
-          <p:cNvPicPr>
-            <a:picLocks noChangeAspect="1"/>
-          </p:cNvPicPr>
+      <p:sp>
+        <p:nvSpPr>
+          <p:cNvPr id="3" name="Rectangle 2">
+            <a:extLst>
+              <a:ext uri="{FF2B5EF4-FFF2-40B4-BE49-F238E27FC236}">
+                <a16:creationId xmlns:a16="http://schemas.microsoft.com/office/drawing/2014/main" id="{2476CFE0-1662-7E01-214A-32E6B228B22E}"/>
+              </a:ext>
+            </a:extLst>
+          </p:cNvPr>
+          <p:cNvSpPr/>
           <p:nvPr/>
-        </p:nvPicPr>
-        <p:blipFill>
-          <a:blip r:embed="rId3">
-            <a:extLst>
-              <a:ext uri="{28A0092B-C50C-407E-A947-70E740481C1C}">
-                <a14:useLocalDpi xmlns:a14="http://schemas.microsoft.com/office/drawing/2010/main" val="0"/>
-              </a:ext>
-            </a:extLst>
-          </a:blip>
-          <a:stretch>
-            <a:fillRect/>
-          </a:stretch>
-        </p:blipFill>
+        </p:nvSpPr>
         <p:spPr>
           <a:xfrm>
-            <a:off x="1598753" y="1331495"/>
-            <a:ext cx="8994494" cy="5299490"/>
-          </a:xfrm>
-          <a:prstGeom prst="rect">
-            <a:avLst/>
-          </a:prstGeom>
-        </p:spPr>
-      </p:pic>
-    </p:spTree>
-    <p:extLst>
-      <p:ext uri="{BB962C8B-B14F-4D97-AF65-F5344CB8AC3E}">
-        <p14:creationId xmlns:p14="http://schemas.microsoft.com/office/powerpoint/2010/main" val="1867381965"/>
-      </p:ext>
-    </p:extLst>
-  </p:cSld>
-  <p:clrMapOvr>
-    <a:masterClrMapping/>
-  </p:clrMapOvr>
-</p:sld>
-</file>
-
-<file path=ppt/slides/slide3.xml><?xml version="1.0" encoding="utf-8"?>
-<p:sld xmlns:a="http://schemas.openxmlformats.org/drawingml/2006/main" xmlns:r="http://schemas.openxmlformats.org/officeDocument/2006/relationships" xmlns:p="http://schemas.openxmlformats.org/presentationml/2006/main">
-  <p:cSld>
-    <p:bg>
-      <p:bgPr>
-        <a:blipFill dpi="0" rotWithShape="1">
-          <a:blip r:embed="rId2">
-            <a:lum/>
-          </a:blip>
-          <a:srcRect/>
-          <a:stretch>
-            <a:fillRect/>
-          </a:stretch>
-        </a:blipFill>
-        <a:effectLst/>
-      </p:bgPr>
-    </p:bg>
-    <p:spTree>
-      <p:nvGrpSpPr>
-        <p:cNvPr id="1" name="">
-          <a:extLst>
-            <a:ext uri="{FF2B5EF4-FFF2-40B4-BE49-F238E27FC236}">
-              <a16:creationId xmlns:a16="http://schemas.microsoft.com/office/drawing/2014/main" id="{E3EECA98-9D12-9A0E-9808-9A3886260B04}"/>
-            </a:ext>
-          </a:extLst>
-        </p:cNvPr>
-        <p:cNvGrpSpPr/>
-        <p:nvPr/>
-      </p:nvGrpSpPr>
-      <p:grpSpPr>
-        <a:xfrm>
-          <a:off x="0" y="0"/>
-          <a:ext cx="0" cy="0"/>
-          <a:chOff x="0" y="0"/>
-          <a:chExt cx="0" cy="0"/>
-        </a:xfrm>
-      </p:grpSpPr>
-      <p:sp>
-        <p:nvSpPr>
-          <p:cNvPr id="2" name="TextBox 1">
-            <a:extLst>
-              <a:ext uri="{FF2B5EF4-FFF2-40B4-BE49-F238E27FC236}">
-                <a16:creationId xmlns:a16="http://schemas.microsoft.com/office/drawing/2014/main" id="{5EF00748-31E3-6DAB-197F-7A21A62B9ECE}"/>
-              </a:ext>
-            </a:extLst>
-          </p:cNvPr>
-          <p:cNvSpPr txBox="1"/>
-          <p:nvPr/>
-        </p:nvSpPr>
-        <p:spPr>
-          <a:xfrm>
-            <a:off x="368968" y="419521"/>
-            <a:ext cx="11454063" cy="707886"/>
+            <a:off x="1194390" y="2239540"/>
+            <a:ext cx="9803219" cy="2378920"/>
           </a:xfrm>
           <a:prstGeom prst="rect">
             <a:avLst/>
@@ -3713,122 +3700,43 @@
           <a:solidFill>
             <a:schemeClr val="bg1"/>
           </a:solidFill>
+          <a:ln>
+            <a:solidFill>
+              <a:schemeClr val="bg1"/>
+            </a:solidFill>
+          </a:ln>
         </p:spPr>
-        <p:txBody>
-          <a:bodyPr wrap="square" rtlCol="0">
-            <a:spAutoFit/>
-          </a:bodyPr>
-          <a:lstStyle/>
-          <a:p>
-            <a:pPr algn="ctr"/>
-            <a:r>
-              <a:rPr lang="en-US" sz="4000" dirty="0">
-                <a:solidFill>
-                  <a:srgbClr val="C00000"/>
-                </a:solidFill>
-              </a:rPr>
-              <a:t>Concept 1: Precision Joint with Preloaded Bearings</a:t>
-            </a:r>
-            <a:endParaRPr lang="en-ZA" sz="4000" dirty="0">
-              <a:solidFill>
-                <a:srgbClr val="C00000"/>
-              </a:solidFill>
-            </a:endParaRPr>
-          </a:p>
-        </p:txBody>
-      </p:sp>
-      <p:pic>
-        <p:nvPicPr>
-          <p:cNvPr id="4" name="Picture 3">
-            <a:extLst>
-              <a:ext uri="{FF2B5EF4-FFF2-40B4-BE49-F238E27FC236}">
-                <a16:creationId xmlns:a16="http://schemas.microsoft.com/office/drawing/2014/main" id="{52E061C6-97A3-1489-8055-DE24DCF0C89D}"/>
-              </a:ext>
-            </a:extLst>
-          </p:cNvPr>
-          <p:cNvPicPr>
-            <a:picLocks noChangeAspect="1"/>
-          </p:cNvPicPr>
-          <p:nvPr/>
-        </p:nvPicPr>
-        <p:blipFill>
-          <a:blip r:embed="rId3">
-            <a:extLst>
-              <a:ext uri="{28A0092B-C50C-407E-A947-70E740481C1C}">
-                <a14:useLocalDpi xmlns:a14="http://schemas.microsoft.com/office/drawing/2010/main" val="0"/>
-              </a:ext>
-            </a:extLst>
-          </a:blip>
-          <a:stretch>
-            <a:fillRect/>
-          </a:stretch>
-        </p:blipFill>
-        <p:spPr>
-          <a:xfrm>
-            <a:off x="368968" y="1127407"/>
-            <a:ext cx="3210118" cy="5311072"/>
-          </a:xfrm>
-          <a:prstGeom prst="rect">
-            <a:avLst/>
-          </a:prstGeom>
-        </p:spPr>
-      </p:pic>
-      <p:sp>
-        <p:nvSpPr>
-          <p:cNvPr id="5" name="TextBox 4">
-            <a:extLst>
-              <a:ext uri="{FF2B5EF4-FFF2-40B4-BE49-F238E27FC236}">
-                <a16:creationId xmlns:a16="http://schemas.microsoft.com/office/drawing/2014/main" id="{9E98F96D-AD6B-725A-05AD-1BEC5C7F91AA}"/>
-              </a:ext>
-            </a:extLst>
-          </p:cNvPr>
-          <p:cNvSpPr txBox="1"/>
-          <p:nvPr/>
-        </p:nvSpPr>
-        <p:spPr>
-          <a:xfrm>
-            <a:off x="3882189" y="1127407"/>
-            <a:ext cx="7940842" cy="5078313"/>
-          </a:xfrm>
-          <a:prstGeom prst="rect">
-            <a:avLst/>
-          </a:prstGeom>
-          <a:solidFill>
-            <a:schemeClr val="bg1"/>
-          </a:solidFill>
-        </p:spPr>
-        <p:txBody>
-          <a:bodyPr wrap="square" rtlCol="0">
-            <a:spAutoFit/>
-          </a:bodyPr>
-          <a:lstStyle/>
-          <a:p>
-            <a:r>
-              <a:rPr lang="en-US" b="1" dirty="0">
-                <a:solidFill>
-                  <a:srgbClr val="C00000"/>
-                </a:solidFill>
-              </a:rPr>
-              <a:t>Key Components</a:t>
-            </a:r>
-            <a:endParaRPr lang="en-US" dirty="0">
-              <a:solidFill>
-                <a:srgbClr val="C00000"/>
-              </a:solidFill>
-            </a:endParaRPr>
-          </a:p>
+        <p:style>
+          <a:lnRef idx="2">
+            <a:schemeClr val="accent1">
+              <a:shade val="15000"/>
+            </a:schemeClr>
+          </a:lnRef>
+          <a:fillRef idx="1">
+            <a:schemeClr val="accent1"/>
+          </a:fillRef>
+          <a:effectRef idx="0">
+            <a:schemeClr val="accent1"/>
+          </a:effectRef>
+          <a:fontRef idx="minor">
+            <a:schemeClr val="lt1"/>
+          </a:fontRef>
+        </p:style>
+        <p:txBody>
+          <a:bodyPr rtlCol="0" anchor="ctr"/>
+          <a:lstStyle/>
           <a:p>
             <a:pPr marL="285750" indent="-285750">
               <a:buFont typeface="Arial" panose="020B0604020202020204" pitchFamily="34" charset="0"/>
               <a:buChar char="•"/>
             </a:pPr>
             <a:r>
-              <a:rPr lang="en-US" b="1" dirty="0"/>
-              <a:t>Shaft:</a:t>
-            </a:r>
-            <a:r>
-              <a:rPr lang="en-US" dirty="0"/>
-              <a:t> Rotating element that transmits motion to the output link</a:t>
+              <a:rPr lang="en-US" dirty="0">
+                <a:solidFill>
+                  <a:schemeClr val="tx1"/>
+                </a:solidFill>
+              </a:rPr>
+              <a:t>Going through final report feedback and up dating</a:t>
             </a:r>
           </a:p>
           <a:p>
@@ -3837,12 +3745,12 @@
               <a:buChar char="•"/>
             </a:pPr>
             <a:r>
-              <a:rPr lang="en-US" b="1" dirty="0"/>
-              <a:t>Joint Housing:</a:t>
-            </a:r>
-            <a:r>
-              <a:rPr lang="en-US" dirty="0"/>
-              <a:t> Fixed outer casing, lightweight and rigid</a:t>
+              <a:rPr lang="en-US" dirty="0">
+                <a:solidFill>
+                  <a:schemeClr val="tx1"/>
+                </a:solidFill>
+              </a:rPr>
+              <a:t>Drawings were handed in to the workshop last week Wednesday</a:t>
             </a:r>
           </a:p>
           <a:p>
@@ -3851,13 +3759,58 @@
               <a:buChar char="•"/>
             </a:pPr>
             <a:r>
-              <a:rPr lang="en-US" b="1" dirty="0"/>
-              <a:t>Angular Contact Bearings (×2)</a:t>
-            </a:r>
-            <a:r>
-              <a:rPr lang="en-US" dirty="0"/>
-              <a:t> — Handle radial and axial loads; resist tilting forces</a:t>
-            </a:r>
+              <a:rPr lang="en-US" dirty="0">
+                <a:solidFill>
+                  <a:schemeClr val="tx1"/>
+                </a:solidFill>
+              </a:rPr>
+              <a:t>RS components have been received, </a:t>
+            </a:r>
+            <a:r>
+              <a:rPr lang="en-US" dirty="0" err="1">
+                <a:solidFill>
+                  <a:schemeClr val="tx1"/>
+                </a:solidFill>
+              </a:rPr>
+              <a:t>MicroRobotics</a:t>
+            </a:r>
+            <a:r>
+              <a:rPr lang="en-US" dirty="0">
+                <a:solidFill>
+                  <a:schemeClr val="tx1"/>
+                </a:solidFill>
+              </a:rPr>
+              <a:t> </a:t>
+            </a:r>
+            <a:r>
+              <a:rPr lang="en-US" dirty="0" err="1">
+                <a:solidFill>
+                  <a:schemeClr val="tx1"/>
+                </a:solidFill>
+              </a:rPr>
+              <a:t>componented</a:t>
+            </a:r>
+            <a:r>
+              <a:rPr lang="en-US" dirty="0">
+                <a:solidFill>
+                  <a:schemeClr val="tx1"/>
+                </a:solidFill>
+              </a:rPr>
+              <a:t> to be collected at </a:t>
+            </a:r>
+            <a:r>
+              <a:rPr lang="en-US" dirty="0" err="1">
+                <a:solidFill>
+                  <a:schemeClr val="tx1"/>
+                </a:solidFill>
+              </a:rPr>
+              <a:t>TechnoPark</a:t>
+            </a:r>
+            <a:endParaRPr lang="en-US" dirty="0">
+              <a:solidFill>
+                <a:schemeClr val="tx1"/>
+              </a:solidFill>
+            </a:endParaRPr>
           </a:p>
           <a:p>
             <a:pPr marL="285750" indent="-285750">
@@ -3865,13 +3818,26 @@
               <a:buChar char="•"/>
             </a:pPr>
             <a:r>
-              <a:rPr lang="en-US" b="1" dirty="0"/>
-              <a:t>Belleville Washers: </a:t>
-            </a:r>
-            <a:r>
-              <a:rPr lang="en-US" dirty="0"/>
-              <a:t>Conical spring washers that apply continuous preload force</a:t>
-            </a:r>
+              <a:rPr lang="en-US" dirty="0">
+                <a:solidFill>
+                  <a:schemeClr val="tx1"/>
+                </a:solidFill>
+              </a:rPr>
+              <a:t>Started safety report, will contact and consult with Prof. Blaine for </a:t>
+            </a:r>
+            <a:r>
+              <a:rPr lang="en-US">
+                <a:solidFill>
+                  <a:schemeClr val="tx1"/>
+                </a:solidFill>
+              </a:rPr>
+              <a:t>strain gauges</a:t>
+            </a:r>
+            <a:endParaRPr lang="en-US" dirty="0">
+              <a:solidFill>
+                <a:schemeClr val="tx1"/>
+              </a:solidFill>
+            </a:endParaRPr>
           </a:p>
           <a:p>
             <a:pPr marL="285750" indent="-285750">
@@ -3879,61 +3845,12 @@
               <a:buChar char="•"/>
             </a:pPr>
             <a:r>
-              <a:rPr lang="en-US" b="1" dirty="0"/>
-              <a:t>Preload Nut: </a:t>
-            </a:r>
-            <a:r>
-              <a:rPr lang="en-US" dirty="0"/>
-              <a:t>Compresses washers to eliminate all internal bearing clearance</a:t>
-            </a:r>
-          </a:p>
-          <a:p>
-            <a:pPr marL="285750" indent="-285750">
-              <a:buFont typeface="Arial" panose="020B0604020202020204" pitchFamily="34" charset="0"/>
-              <a:buChar char="•"/>
-            </a:pPr>
-            <a:r>
-              <a:rPr lang="en-US" b="1" dirty="0"/>
-              <a:t>Rotary Encoder (Coaxial):</a:t>
-            </a:r>
-            <a:r>
-              <a:rPr lang="en-US" dirty="0"/>
-              <a:t> Measures shaft angle θ directly with high resolution</a:t>
-            </a:r>
-          </a:p>
-          <a:p>
-            <a:pPr marL="285750" indent="-285750">
-              <a:buFont typeface="Arial" panose="020B0604020202020204" pitchFamily="34" charset="0"/>
-              <a:buChar char="•"/>
-            </a:pPr>
-            <a:r>
-              <a:rPr lang="en-US" b="1" dirty="0"/>
-              <a:t>Upper Link / Lower Link:</a:t>
-            </a:r>
-            <a:r>
-              <a:rPr lang="en-US" dirty="0"/>
-              <a:t> Fixed input side and rotating output side of the joint</a:t>
-            </a:r>
-          </a:p>
-          <a:p>
-            <a:r>
-              <a:rPr lang="en-US" b="1" dirty="0">
+              <a:rPr lang="en-ZA" dirty="0">
                 <a:solidFill>
-                  <a:srgbClr val="C00000"/>
+                  <a:schemeClr val="tx1"/>
                 </a:solidFill>
               </a:rPr>
-              <a:t>How It Works</a:t>
-            </a:r>
-            <a:endParaRPr lang="en-US" dirty="0">
-              <a:solidFill>
-                <a:srgbClr val="C00000"/>
-              </a:solidFill>
-            </a:endParaRPr>
-          </a:p>
-          <a:p>
-            <a:r>
-              <a:rPr lang="en-US" dirty="0"/>
-              <a:t>Preload nut and Belleville washers squeeze out all internal clearance from the bearings. No "dead zone" when rotation reverses, the joint responds immediately and repeatably. Coaxial encoder reads exact angle with no mechanical linkage error.</a:t>
+              <a:t>Software development will begin this weekend</a:t>
             </a:r>
           </a:p>
         </p:txBody>
@@ -3941,517 +3858,7 @@
     </p:spTree>
     <p:extLst>
       <p:ext uri="{BB962C8B-B14F-4D97-AF65-F5344CB8AC3E}">
-        <p14:creationId xmlns:p14="http://schemas.microsoft.com/office/powerpoint/2010/main" val="3061533499"/>
-      </p:ext>
-    </p:extLst>
-  </p:cSld>
-  <p:clrMapOvr>
-    <a:masterClrMapping/>
-  </p:clrMapOvr>
-</p:sld>
-</file>
-
-<file path=ppt/slides/slide4.xml><?xml version="1.0" encoding="utf-8"?>
-<p:sld xmlns:a="http://schemas.openxmlformats.org/drawingml/2006/main" xmlns:r="http://schemas.openxmlformats.org/officeDocument/2006/relationships" xmlns:p="http://schemas.openxmlformats.org/presentationml/2006/main">
-  <p:cSld>
-    <p:bg>
-      <p:bgPr>
-        <a:blipFill dpi="0" rotWithShape="1">
-          <a:blip r:embed="rId2">
-            <a:lum/>
-          </a:blip>
-          <a:srcRect/>
-          <a:stretch>
-            <a:fillRect/>
-          </a:stretch>
-        </a:blipFill>
-        <a:effectLst/>
-      </p:bgPr>
-    </p:bg>
-    <p:spTree>
-      <p:nvGrpSpPr>
-        <p:cNvPr id="1" name="">
-          <a:extLst>
-            <a:ext uri="{FF2B5EF4-FFF2-40B4-BE49-F238E27FC236}">
-              <a16:creationId xmlns:a16="http://schemas.microsoft.com/office/drawing/2014/main" id="{09B8BC87-7310-3656-7CE7-F04FEC07F412}"/>
-            </a:ext>
-          </a:extLst>
-        </p:cNvPr>
-        <p:cNvGrpSpPr/>
-        <p:nvPr/>
-      </p:nvGrpSpPr>
-      <p:grpSpPr>
-        <a:xfrm>
-          <a:off x="0" y="0"/>
-          <a:ext cx="0" cy="0"/>
-          <a:chOff x="0" y="0"/>
-          <a:chExt cx="0" cy="0"/>
-        </a:xfrm>
-      </p:grpSpPr>
-      <p:sp>
-        <p:nvSpPr>
-          <p:cNvPr id="2" name="TextBox 1">
-            <a:extLst>
-              <a:ext uri="{FF2B5EF4-FFF2-40B4-BE49-F238E27FC236}">
-                <a16:creationId xmlns:a16="http://schemas.microsoft.com/office/drawing/2014/main" id="{1FBC9687-99FD-AF53-E22F-E490D7661E8E}"/>
-              </a:ext>
-            </a:extLst>
-          </p:cNvPr>
-          <p:cNvSpPr txBox="1"/>
-          <p:nvPr/>
-        </p:nvSpPr>
-        <p:spPr>
-          <a:xfrm>
-            <a:off x="1456932" y="430538"/>
-            <a:ext cx="9278135" cy="707886"/>
-          </a:xfrm>
-          <a:prstGeom prst="rect">
-            <a:avLst/>
-          </a:prstGeom>
-          <a:solidFill>
-            <a:schemeClr val="bg1"/>
-          </a:solidFill>
-        </p:spPr>
-        <p:txBody>
-          <a:bodyPr wrap="square" rtlCol="0">
-            <a:spAutoFit/>
-          </a:bodyPr>
-          <a:lstStyle/>
-          <a:p>
-            <a:pPr algn="ctr"/>
-            <a:r>
-              <a:rPr lang="en-US" sz="4000" dirty="0">
-                <a:solidFill>
-                  <a:srgbClr val="C00000"/>
-                </a:solidFill>
-              </a:rPr>
-              <a:t>Concept 2: Counterbalanced Joint</a:t>
-            </a:r>
-            <a:endParaRPr lang="en-ZA" sz="4000" dirty="0">
-              <a:solidFill>
-                <a:srgbClr val="C00000"/>
-              </a:solidFill>
-            </a:endParaRPr>
-          </a:p>
-        </p:txBody>
-      </p:sp>
-      <p:pic>
-        <p:nvPicPr>
-          <p:cNvPr id="4" name="Picture 3">
-            <a:extLst>
-              <a:ext uri="{FF2B5EF4-FFF2-40B4-BE49-F238E27FC236}">
-                <a16:creationId xmlns:a16="http://schemas.microsoft.com/office/drawing/2014/main" id="{6AD8D426-4B66-0F41-67C1-DF6DFB64D1F6}"/>
-              </a:ext>
-            </a:extLst>
-          </p:cNvPr>
-          <p:cNvPicPr>
-            <a:picLocks noChangeAspect="1"/>
-          </p:cNvPicPr>
-          <p:nvPr/>
-        </p:nvPicPr>
-        <p:blipFill>
-          <a:blip r:embed="rId3">
-            <a:extLst>
-              <a:ext uri="{28A0092B-C50C-407E-A947-70E740481C1C}">
-                <a14:useLocalDpi xmlns:a14="http://schemas.microsoft.com/office/drawing/2010/main" val="0"/>
-              </a:ext>
-            </a:extLst>
-          </a:blip>
-          <a:stretch>
-            <a:fillRect/>
-          </a:stretch>
-        </p:blipFill>
-        <p:spPr>
-          <a:xfrm>
-            <a:off x="150467" y="1054123"/>
-            <a:ext cx="3033407" cy="5803877"/>
-          </a:xfrm>
-          <a:prstGeom prst="rect">
-            <a:avLst/>
-          </a:prstGeom>
-        </p:spPr>
-      </p:pic>
-      <p:sp>
-        <p:nvSpPr>
-          <p:cNvPr id="5" name="TextBox 4">
-            <a:extLst>
-              <a:ext uri="{FF2B5EF4-FFF2-40B4-BE49-F238E27FC236}">
-                <a16:creationId xmlns:a16="http://schemas.microsoft.com/office/drawing/2014/main" id="{8A1DC8EF-1AB7-0D5A-5993-2202E82671E6}"/>
-              </a:ext>
-            </a:extLst>
-          </p:cNvPr>
-          <p:cNvSpPr txBox="1"/>
-          <p:nvPr/>
-        </p:nvSpPr>
-        <p:spPr>
-          <a:xfrm>
-            <a:off x="3459297" y="2247901"/>
-            <a:ext cx="8374751" cy="3139321"/>
-          </a:xfrm>
-          <a:prstGeom prst="rect">
-            <a:avLst/>
-          </a:prstGeom>
-          <a:solidFill>
-            <a:schemeClr val="bg1"/>
-          </a:solidFill>
-        </p:spPr>
-        <p:txBody>
-          <a:bodyPr wrap="square" rtlCol="0">
-            <a:spAutoFit/>
-          </a:bodyPr>
-          <a:lstStyle/>
-          <a:p>
-            <a:r>
-              <a:rPr lang="en-US" b="1" dirty="0">
-                <a:solidFill>
-                  <a:srgbClr val="C00000"/>
-                </a:solidFill>
-              </a:rPr>
-              <a:t>Key Components</a:t>
-            </a:r>
-            <a:endParaRPr lang="en-US" dirty="0">
-              <a:solidFill>
-                <a:srgbClr val="C00000"/>
-              </a:solidFill>
-            </a:endParaRPr>
-          </a:p>
-          <a:p>
-            <a:pPr marL="285750" indent="-285750">
-              <a:buFont typeface="Arial" panose="020B0604020202020204" pitchFamily="34" charset="0"/>
-              <a:buChar char="•"/>
-            </a:pPr>
-            <a:r>
-              <a:rPr lang="en-US" dirty="0"/>
-              <a:t>All components from Concept 1 (shaft, housing, bearings, encoder), in addition to:</a:t>
-            </a:r>
-          </a:p>
-          <a:p>
-            <a:pPr marL="742950" lvl="1" indent="-285750">
-              <a:buFont typeface="Arial" panose="020B0604020202020204" pitchFamily="34" charset="0"/>
-              <a:buChar char="•"/>
-            </a:pPr>
-            <a:r>
-              <a:rPr lang="en-US" b="1" dirty="0"/>
-              <a:t>Counterbalance Torsion Spring:</a:t>
-            </a:r>
-            <a:r>
-              <a:rPr lang="en-US" dirty="0"/>
-              <a:t> Stores and releases rotational energy</a:t>
-            </a:r>
-          </a:p>
-          <a:p>
-            <a:pPr marL="742950" lvl="1" indent="-285750">
-              <a:buFont typeface="Arial" panose="020B0604020202020204" pitchFamily="34" charset="0"/>
-              <a:buChar char="•"/>
-            </a:pPr>
-            <a:r>
-              <a:rPr lang="en-US" b="1" dirty="0"/>
-              <a:t>Spring Attachment Point:</a:t>
-            </a:r>
-            <a:r>
-              <a:rPr lang="en-US" dirty="0"/>
-              <a:t> Connects spring between housing and shaft</a:t>
-            </a:r>
-          </a:p>
-          <a:p>
-            <a:endParaRPr lang="en-US" dirty="0"/>
-          </a:p>
-          <a:p>
-            <a:r>
-              <a:rPr lang="en-US" b="1" dirty="0">
-                <a:solidFill>
-                  <a:srgbClr val="C00000"/>
-                </a:solidFill>
-              </a:rPr>
-              <a:t>How It Works</a:t>
-            </a:r>
-            <a:endParaRPr lang="en-US" dirty="0">
-              <a:solidFill>
-                <a:srgbClr val="C00000"/>
-              </a:solidFill>
-            </a:endParaRPr>
-          </a:p>
-          <a:p>
-            <a:r>
-              <a:rPr lang="en-US" dirty="0"/>
-              <a:t>As the arm link rotates downward under gravity, the torsion spring winds up and stores energy. The spring applies an opposing torque that cancels the gravitational load. Motor only works against dynamic movement, not continuously fighting gravity. Spring stiffness is tuned to match the specific weight of the distal link.</a:t>
-            </a:r>
-          </a:p>
-        </p:txBody>
-      </p:sp>
-    </p:spTree>
-    <p:extLst>
-      <p:ext uri="{BB962C8B-B14F-4D97-AF65-F5344CB8AC3E}">
-        <p14:creationId xmlns:p14="http://schemas.microsoft.com/office/powerpoint/2010/main" val="3534100090"/>
-      </p:ext>
-    </p:extLst>
-  </p:cSld>
-  <p:clrMapOvr>
-    <a:masterClrMapping/>
-  </p:clrMapOvr>
-</p:sld>
-</file>
-
-<file path=ppt/slides/slide5.xml><?xml version="1.0" encoding="utf-8"?>
-<p:sld xmlns:a="http://schemas.openxmlformats.org/drawingml/2006/main" xmlns:r="http://schemas.openxmlformats.org/officeDocument/2006/relationships" xmlns:p="http://schemas.openxmlformats.org/presentationml/2006/main">
-  <p:cSld>
-    <p:bg>
-      <p:bgPr>
-        <a:blipFill dpi="0" rotWithShape="1">
-          <a:blip r:embed="rId2">
-            <a:lum/>
-          </a:blip>
-          <a:srcRect/>
-          <a:stretch>
-            <a:fillRect/>
-          </a:stretch>
-        </a:blipFill>
-        <a:effectLst/>
-      </p:bgPr>
-    </p:bg>
-    <p:spTree>
-      <p:nvGrpSpPr>
-        <p:cNvPr id="1" name="">
-          <a:extLst>
-            <a:ext uri="{FF2B5EF4-FFF2-40B4-BE49-F238E27FC236}">
-              <a16:creationId xmlns:a16="http://schemas.microsoft.com/office/drawing/2014/main" id="{F3C6E76E-5A3E-1F23-D163-2CB383DBDE55}"/>
-            </a:ext>
-          </a:extLst>
-        </p:cNvPr>
-        <p:cNvGrpSpPr/>
-        <p:nvPr/>
-      </p:nvGrpSpPr>
-      <p:grpSpPr>
-        <a:xfrm>
-          <a:off x="0" y="0"/>
-          <a:ext cx="0" cy="0"/>
-          <a:chOff x="0" y="0"/>
-          <a:chExt cx="0" cy="0"/>
-        </a:xfrm>
-      </p:grpSpPr>
-      <p:sp>
-        <p:nvSpPr>
-          <p:cNvPr id="2" name="TextBox 1">
-            <a:extLst>
-              <a:ext uri="{FF2B5EF4-FFF2-40B4-BE49-F238E27FC236}">
-                <a16:creationId xmlns:a16="http://schemas.microsoft.com/office/drawing/2014/main" id="{F1D5AA3A-CA8E-B6DD-ADB7-8FE7D4CDE0E8}"/>
-              </a:ext>
-            </a:extLst>
-          </p:cNvPr>
-          <p:cNvSpPr txBox="1"/>
-          <p:nvPr/>
-        </p:nvSpPr>
-        <p:spPr>
-          <a:xfrm>
-            <a:off x="1456932" y="430538"/>
-            <a:ext cx="9278135" cy="707886"/>
-          </a:xfrm>
-          <a:prstGeom prst="rect">
-            <a:avLst/>
-          </a:prstGeom>
-          <a:solidFill>
-            <a:schemeClr val="bg1"/>
-          </a:solidFill>
-        </p:spPr>
-        <p:txBody>
-          <a:bodyPr wrap="square" rtlCol="0">
-            <a:spAutoFit/>
-          </a:bodyPr>
-          <a:lstStyle/>
-          <a:p>
-            <a:pPr algn="ctr"/>
-            <a:r>
-              <a:rPr lang="en-US" sz="4000" dirty="0">
-                <a:solidFill>
-                  <a:srgbClr val="C00000"/>
-                </a:solidFill>
-              </a:rPr>
-              <a:t>Concept 3: Active Brake Joint</a:t>
-            </a:r>
-            <a:endParaRPr lang="en-ZA" sz="4000" dirty="0">
-              <a:solidFill>
-                <a:srgbClr val="C00000"/>
-              </a:solidFill>
-            </a:endParaRPr>
-          </a:p>
-        </p:txBody>
-      </p:sp>
-      <p:pic>
-        <p:nvPicPr>
-          <p:cNvPr id="4" name="Picture 3">
-            <a:extLst>
-              <a:ext uri="{FF2B5EF4-FFF2-40B4-BE49-F238E27FC236}">
-                <a16:creationId xmlns:a16="http://schemas.microsoft.com/office/drawing/2014/main" id="{4037E25C-BDF3-32CC-86D8-F7705FEAC1F6}"/>
-              </a:ext>
-            </a:extLst>
-          </p:cNvPr>
-          <p:cNvPicPr>
-            <a:picLocks noChangeAspect="1"/>
-          </p:cNvPicPr>
-          <p:nvPr/>
-        </p:nvPicPr>
-        <p:blipFill>
-          <a:blip r:embed="rId3">
-            <a:extLst>
-              <a:ext uri="{28A0092B-C50C-407E-A947-70E740481C1C}">
-                <a14:useLocalDpi xmlns:a14="http://schemas.microsoft.com/office/drawing/2010/main" val="0"/>
-              </a:ext>
-            </a:extLst>
-          </a:blip>
-          <a:stretch>
-            <a:fillRect/>
-          </a:stretch>
-        </p:blipFill>
-        <p:spPr>
-          <a:xfrm>
-            <a:off x="324226" y="1103869"/>
-            <a:ext cx="3344390" cy="5754131"/>
-          </a:xfrm>
-          <a:prstGeom prst="rect">
-            <a:avLst/>
-          </a:prstGeom>
-        </p:spPr>
-      </p:pic>
-      <p:sp>
-        <p:nvSpPr>
-          <p:cNvPr id="5" name="TextBox 4">
-            <a:extLst>
-              <a:ext uri="{FF2B5EF4-FFF2-40B4-BE49-F238E27FC236}">
-                <a16:creationId xmlns:a16="http://schemas.microsoft.com/office/drawing/2014/main" id="{EE2D1835-0713-267D-7B6C-2B1B6FAF6348}"/>
-              </a:ext>
-            </a:extLst>
-          </p:cNvPr>
-          <p:cNvSpPr txBox="1"/>
-          <p:nvPr/>
-        </p:nvSpPr>
-        <p:spPr>
-          <a:xfrm>
-            <a:off x="3926932" y="1857275"/>
-            <a:ext cx="7940842" cy="4247317"/>
-          </a:xfrm>
-          <a:prstGeom prst="rect">
-            <a:avLst/>
-          </a:prstGeom>
-          <a:solidFill>
-            <a:schemeClr val="bg1"/>
-          </a:solidFill>
-        </p:spPr>
-        <p:txBody>
-          <a:bodyPr wrap="square" rtlCol="0">
-            <a:spAutoFit/>
-          </a:bodyPr>
-          <a:lstStyle/>
-          <a:p>
-            <a:r>
-              <a:rPr lang="en-US" b="1" dirty="0">
-                <a:solidFill>
-                  <a:srgbClr val="C00000"/>
-                </a:solidFill>
-              </a:rPr>
-              <a:t>Key Components</a:t>
-            </a:r>
-            <a:endParaRPr lang="en-US" dirty="0">
-              <a:solidFill>
-                <a:srgbClr val="C00000"/>
-              </a:solidFill>
-            </a:endParaRPr>
-          </a:p>
-          <a:p>
-            <a:pPr marL="285750" indent="-285750">
-              <a:buFont typeface="Arial" panose="020B0604020202020204" pitchFamily="34" charset="0"/>
-              <a:buChar char="•"/>
-            </a:pPr>
-            <a:r>
-              <a:rPr lang="en-US" dirty="0"/>
-              <a:t>All components from Concept 1 (shaft, housing, bearings, encoder), including:</a:t>
-            </a:r>
-          </a:p>
-          <a:p>
-            <a:pPr marL="742950" lvl="1" indent="-285750">
-              <a:buFont typeface="Arial" panose="020B0604020202020204" pitchFamily="34" charset="0"/>
-              <a:buChar char="•"/>
-            </a:pPr>
-            <a:r>
-              <a:rPr lang="en-US" b="1" dirty="0"/>
-              <a:t>Electromagnetic Coil (Fixed): </a:t>
-            </a:r>
-            <a:r>
-              <a:rPr lang="en-US" dirty="0"/>
-              <a:t>Generates magnetic field when energized</a:t>
-            </a:r>
-          </a:p>
-          <a:p>
-            <a:pPr marL="742950" lvl="1" indent="-285750">
-              <a:buFont typeface="Arial" panose="020B0604020202020204" pitchFamily="34" charset="0"/>
-              <a:buChar char="•"/>
-            </a:pPr>
-            <a:r>
-              <a:rPr lang="en-US" b="1" dirty="0"/>
-              <a:t>Friction Plate (Fixed to Housing): </a:t>
-            </a:r>
-            <a:r>
-              <a:rPr lang="en-US" dirty="0"/>
-              <a:t>Stationary braking surface</a:t>
-            </a:r>
-          </a:p>
-          <a:p>
-            <a:pPr marL="742950" lvl="1" indent="-285750">
-              <a:buFont typeface="Arial" panose="020B0604020202020204" pitchFamily="34" charset="0"/>
-              <a:buChar char="•"/>
-            </a:pPr>
-            <a:r>
-              <a:rPr lang="en-US" b="1" dirty="0"/>
-              <a:t>Brake Disc (Attached to Shaft)</a:t>
-            </a:r>
-            <a:r>
-              <a:rPr lang="en-US" dirty="0"/>
-              <a:t>: Rotates with shaft; sits between coil and friction plate</a:t>
-            </a:r>
-          </a:p>
-          <a:p>
-            <a:pPr marL="742950" lvl="1" indent="-285750">
-              <a:buFont typeface="Arial" panose="020B0604020202020204" pitchFamily="34" charset="0"/>
-              <a:buChar char="•"/>
-            </a:pPr>
-            <a:r>
-              <a:rPr lang="en-US" b="1" dirty="0"/>
-              <a:t>Air Gap: </a:t>
-            </a:r>
-            <a:r>
-              <a:rPr lang="en-US" dirty="0"/>
-              <a:t>Small clearance that allows free movement when brake is off</a:t>
-            </a:r>
-          </a:p>
-          <a:p>
-            <a:endParaRPr lang="en-US" dirty="0"/>
-          </a:p>
-          <a:p>
-            <a:r>
-              <a:rPr lang="en-US" b="1" dirty="0">
-                <a:solidFill>
-                  <a:srgbClr val="C00000"/>
-                </a:solidFill>
-              </a:rPr>
-              <a:t>How It Works</a:t>
-            </a:r>
-            <a:endParaRPr lang="en-US" dirty="0">
-              <a:solidFill>
-                <a:srgbClr val="C00000"/>
-              </a:solidFill>
-            </a:endParaRPr>
-          </a:p>
-          <a:p>
-            <a:r>
-              <a:rPr lang="en-US" dirty="0"/>
-              <a:t>When the brake is OFF, the coil is  de-energized and the air gap prevents contact. Shaft rotates freely with minimal friction. When the brake is ON, the coil is energized and magnetic field closes air gap. Disc clamps against friction plate and joint locks rigidly.</a:t>
-            </a:r>
-          </a:p>
-        </p:txBody>
-      </p:sp>
-    </p:spTree>
-    <p:extLst>
-      <p:ext uri="{BB962C8B-B14F-4D97-AF65-F5344CB8AC3E}">
-        <p14:creationId xmlns:p14="http://schemas.microsoft.com/office/powerpoint/2010/main" val="4190784417"/>
+        <p14:creationId xmlns:p14="http://schemas.microsoft.com/office/powerpoint/2010/main" val="1867381965"/>
       </p:ext>
     </p:extLst>
   </p:cSld>

</xml_diff>

<commit_message>
Safety report completed. I am now going to continue updating my final report.
</commit_message>
<xml_diff>
--- a/Concept design report/Week 9 - Progress Meeting.pptx
+++ b/Concept design report/Week 9 - Progress Meeting.pptx
@@ -7,6 +7,7 @@
   <p:sldIdLst>
     <p:sldId id="256" r:id="rId2"/>
     <p:sldId id="257" r:id="rId3"/>
+    <p:sldId id="258" r:id="rId4"/>
   </p:sldIdLst>
   <p:sldSz cx="12192000" cy="6858000"/>
   <p:notesSz cx="6858000" cy="9144000"/>
@@ -113,23 +114,31 @@
 </p:presentation>
 </file>
 
+<file path=ppt/revisionInfo.xml><?xml version="1.0" encoding="utf-8"?>
+<p1510:revInfo xmlns:a="http://schemas.openxmlformats.org/drawingml/2006/main" xmlns:r="http://schemas.openxmlformats.org/officeDocument/2006/relationships" xmlns:p1510="http://schemas.microsoft.com/office/powerpoint/2015/10/main">
+  <p1510:revLst>
+    <p1510:client id="{9A06E4D8-8A9D-4C58-A628-439B52EB77A5}" v="1" dt="2026-08-25T09:37:04.371"/>
+  </p1510:revLst>
+</p1510:revInfo>
+</file>
+
 <file path=ppt/changesInfos/changesInfo1.xml><?xml version="1.0" encoding="utf-8"?>
 <pc:chgInfo xmlns:a="http://schemas.openxmlformats.org/drawingml/2006/main" xmlns:r="http://schemas.openxmlformats.org/officeDocument/2006/relationships" xmlns:ac="http://schemas.microsoft.com/office/drawing/2013/main/command" xmlns:pc="http://schemas.microsoft.com/office/powerpoint/2013/main/command">
   <pc:docChgLst>
     <pc:chgData name="Matota, LN, Miss [24989142@sun.ac.za]" userId="7a1f7bb1-56ac-4c00-937c-47b0bcb81363" providerId="ADAL" clId="{8B03531C-D65D-4FC7-A92A-A0BB20D20D7C}"/>
     <pc:docChg chg="undo custSel addSld delSld modSld">
-      <pc:chgData name="Matota, LN, Miss [24989142@sun.ac.za]" userId="7a1f7bb1-56ac-4c00-937c-47b0bcb81363" providerId="ADAL" clId="{8B03531C-D65D-4FC7-A92A-A0BB20D20D7C}" dt="2026-08-18T12:05:31.475" v="701" actId="20577"/>
+      <pc:chgData name="Matota, LN, Miss [24989142@sun.ac.za]" userId="7a1f7bb1-56ac-4c00-937c-47b0bcb81363" providerId="ADAL" clId="{8B03531C-D65D-4FC7-A92A-A0BB20D20D7C}" dt="2026-08-25T09:37:28.873" v="1378" actId="20577"/>
       <pc:docMkLst>
         <pc:docMk/>
       </pc:docMkLst>
       <pc:sldChg chg="modSp mod">
-        <pc:chgData name="Matota, LN, Miss [24989142@sun.ac.za]" userId="7a1f7bb1-56ac-4c00-937c-47b0bcb81363" providerId="ADAL" clId="{8B03531C-D65D-4FC7-A92A-A0BB20D20D7C}" dt="2026-08-18T09:42:11.326" v="177" actId="20577"/>
+        <pc:chgData name="Matota, LN, Miss [24989142@sun.ac.za]" userId="7a1f7bb1-56ac-4c00-937c-47b0bcb81363" providerId="ADAL" clId="{8B03531C-D65D-4FC7-A92A-A0BB20D20D7C}" dt="2026-08-25T09:37:28.873" v="1378" actId="20577"/>
         <pc:sldMkLst>
           <pc:docMk/>
           <pc:sldMk cId="3634458474" sldId="256"/>
         </pc:sldMkLst>
         <pc:spChg chg="mod">
-          <ac:chgData name="Matota, LN, Miss [24989142@sun.ac.za]" userId="7a1f7bb1-56ac-4c00-937c-47b0bcb81363" providerId="ADAL" clId="{8B03531C-D65D-4FC7-A92A-A0BB20D20D7C}" dt="2026-08-18T09:38:40.108" v="8" actId="20577"/>
+          <ac:chgData name="Matota, LN, Miss [24989142@sun.ac.za]" userId="7a1f7bb1-56ac-4c00-937c-47b0bcb81363" providerId="ADAL" clId="{8B03531C-D65D-4FC7-A92A-A0BB20D20D7C}" dt="2026-08-25T09:37:28.873" v="1378" actId="20577"/>
           <ac:spMkLst>
             <pc:docMk/>
             <pc:sldMk cId="3634458474" sldId="256"/>
@@ -137,7 +146,7 @@
           </ac:spMkLst>
         </pc:spChg>
         <pc:spChg chg="mod">
-          <ac:chgData name="Matota, LN, Miss [24989142@sun.ac.za]" userId="7a1f7bb1-56ac-4c00-937c-47b0bcb81363" providerId="ADAL" clId="{8B03531C-D65D-4FC7-A92A-A0BB20D20D7C}" dt="2026-08-18T09:42:11.326" v="177" actId="20577"/>
+          <ac:chgData name="Matota, LN, Miss [24989142@sun.ac.za]" userId="7a1f7bb1-56ac-4c00-937c-47b0bcb81363" providerId="ADAL" clId="{8B03531C-D65D-4FC7-A92A-A0BB20D20D7C}" dt="2026-08-25T09:32:21.876" v="772" actId="20577"/>
           <ac:spMkLst>
             <pc:docMk/>
             <pc:sldMk cId="3634458474" sldId="256"/>
@@ -146,7 +155,7 @@
         </pc:spChg>
       </pc:sldChg>
       <pc:sldChg chg="addSp delSp modSp mod">
-        <pc:chgData name="Matota, LN, Miss [24989142@sun.ac.za]" userId="7a1f7bb1-56ac-4c00-937c-47b0bcb81363" providerId="ADAL" clId="{8B03531C-D65D-4FC7-A92A-A0BB20D20D7C}" dt="2026-08-18T12:05:31.475" v="701" actId="20577"/>
+        <pc:chgData name="Matota, LN, Miss [24989142@sun.ac.za]" userId="7a1f7bb1-56ac-4c00-937c-47b0bcb81363" providerId="ADAL" clId="{8B03531C-D65D-4FC7-A92A-A0BB20D20D7C}" dt="2026-08-25T09:35:29.138" v="1135" actId="20577"/>
         <pc:sldMkLst>
           <pc:docMk/>
           <pc:sldMk cId="1867381965" sldId="257"/>
@@ -160,42 +169,36 @@
           </ac:spMkLst>
         </pc:spChg>
         <pc:spChg chg="add mod">
-          <ac:chgData name="Matota, LN, Miss [24989142@sun.ac.za]" userId="7a1f7bb1-56ac-4c00-937c-47b0bcb81363" providerId="ADAL" clId="{8B03531C-D65D-4FC7-A92A-A0BB20D20D7C}" dt="2026-08-18T12:05:31.475" v="701" actId="20577"/>
+          <ac:chgData name="Matota, LN, Miss [24989142@sun.ac.za]" userId="7a1f7bb1-56ac-4c00-937c-47b0bcb81363" providerId="ADAL" clId="{8B03531C-D65D-4FC7-A92A-A0BB20D20D7C}" dt="2026-08-25T09:35:29.138" v="1135" actId="20577"/>
           <ac:spMkLst>
             <pc:docMk/>
             <pc:sldMk cId="1867381965" sldId="257"/>
             <ac:spMk id="3" creationId="{2476CFE0-1662-7E01-214A-32E6B228B22E}"/>
           </ac:spMkLst>
         </pc:spChg>
-        <pc:picChg chg="add del">
-          <ac:chgData name="Matota, LN, Miss [24989142@sun.ac.za]" userId="7a1f7bb1-56ac-4c00-937c-47b0bcb81363" providerId="ADAL" clId="{8B03531C-D65D-4FC7-A92A-A0BB20D20D7C}" dt="2026-08-18T09:43:06.574" v="184" actId="478"/>
-          <ac:picMkLst>
-            <pc:docMk/>
-            <pc:sldMk cId="1867381965" sldId="257"/>
-            <ac:picMk id="4" creationId="{6596B266-A043-3B8B-1A13-E73E984341FC}"/>
-          </ac:picMkLst>
-        </pc:picChg>
       </pc:sldChg>
-      <pc:sldChg chg="add del">
-        <pc:chgData name="Matota, LN, Miss [24989142@sun.ac.za]" userId="7a1f7bb1-56ac-4c00-937c-47b0bcb81363" providerId="ADAL" clId="{8B03531C-D65D-4FC7-A92A-A0BB20D20D7C}" dt="2026-08-18T09:43:52.088" v="190" actId="47"/>
+      <pc:sldChg chg="modSp add mod">
+        <pc:chgData name="Matota, LN, Miss [24989142@sun.ac.za]" userId="7a1f7bb1-56ac-4c00-937c-47b0bcb81363" providerId="ADAL" clId="{8B03531C-D65D-4FC7-A92A-A0BB20D20D7C}" dt="2026-08-25T09:37:15.632" v="1376" actId="20577"/>
         <pc:sldMkLst>
           <pc:docMk/>
-          <pc:sldMk cId="3061533499" sldId="258"/>
+          <pc:sldMk cId="321170222" sldId="258"/>
         </pc:sldMkLst>
-      </pc:sldChg>
-      <pc:sldChg chg="add del">
-        <pc:chgData name="Matota, LN, Miss [24989142@sun.ac.za]" userId="7a1f7bb1-56ac-4c00-937c-47b0bcb81363" providerId="ADAL" clId="{8B03531C-D65D-4FC7-A92A-A0BB20D20D7C}" dt="2026-08-18T09:43:52.088" v="190" actId="47"/>
-        <pc:sldMkLst>
-          <pc:docMk/>
-          <pc:sldMk cId="3534100090" sldId="259"/>
-        </pc:sldMkLst>
-      </pc:sldChg>
-      <pc:sldChg chg="add del">
-        <pc:chgData name="Matota, LN, Miss [24989142@sun.ac.za]" userId="7a1f7bb1-56ac-4c00-937c-47b0bcb81363" providerId="ADAL" clId="{8B03531C-D65D-4FC7-A92A-A0BB20D20D7C}" dt="2026-08-18T09:43:52.088" v="190" actId="47"/>
-        <pc:sldMkLst>
-          <pc:docMk/>
-          <pc:sldMk cId="4190784417" sldId="260"/>
-        </pc:sldMkLst>
+        <pc:spChg chg="mod">
+          <ac:chgData name="Matota, LN, Miss [24989142@sun.ac.za]" userId="7a1f7bb1-56ac-4c00-937c-47b0bcb81363" providerId="ADAL" clId="{8B03531C-D65D-4FC7-A92A-A0BB20D20D7C}" dt="2026-08-25T09:35:44.937" v="1153" actId="20577"/>
+          <ac:spMkLst>
+            <pc:docMk/>
+            <pc:sldMk cId="321170222" sldId="258"/>
+            <ac:spMk id="2" creationId="{FC705E6B-6953-9B97-463A-66E335DE2B38}"/>
+          </ac:spMkLst>
+        </pc:spChg>
+        <pc:spChg chg="mod">
+          <ac:chgData name="Matota, LN, Miss [24989142@sun.ac.za]" userId="7a1f7bb1-56ac-4c00-937c-47b0bcb81363" providerId="ADAL" clId="{8B03531C-D65D-4FC7-A92A-A0BB20D20D7C}" dt="2026-08-25T09:37:15.632" v="1376" actId="20577"/>
+          <ac:spMkLst>
+            <pc:docMk/>
+            <pc:sldMk cId="321170222" sldId="258"/>
+            <ac:spMk id="3" creationId="{6EB54202-9793-E8F1-B053-6A5BEF0A4839}"/>
+          </ac:spMkLst>
+        </pc:spChg>
       </pc:sldChg>
     </pc:docChg>
   </pc:docChgLst>
@@ -351,7 +354,7 @@
           <a:p>
             <a:fld id="{B31332A8-CEAE-4241-9842-981792316C5A}" type="datetimeFigureOut">
               <a:rPr lang="en-ZA" smtClean="0"/>
-              <a:t>2026/08/18</a:t>
+              <a:t>2026/08/25</a:t>
             </a:fld>
             <a:endParaRPr lang="en-ZA"/>
           </a:p>
@@ -551,7 +554,7 @@
           <a:p>
             <a:fld id="{B31332A8-CEAE-4241-9842-981792316C5A}" type="datetimeFigureOut">
               <a:rPr lang="en-ZA" smtClean="0"/>
-              <a:t>2026/08/18</a:t>
+              <a:t>2026/08/25</a:t>
             </a:fld>
             <a:endParaRPr lang="en-ZA"/>
           </a:p>
@@ -761,7 +764,7 @@
           <a:p>
             <a:fld id="{B31332A8-CEAE-4241-9842-981792316C5A}" type="datetimeFigureOut">
               <a:rPr lang="en-ZA" smtClean="0"/>
-              <a:t>2026/08/18</a:t>
+              <a:t>2026/08/25</a:t>
             </a:fld>
             <a:endParaRPr lang="en-ZA"/>
           </a:p>
@@ -961,7 +964,7 @@
           <a:p>
             <a:fld id="{B31332A8-CEAE-4241-9842-981792316C5A}" type="datetimeFigureOut">
               <a:rPr lang="en-ZA" smtClean="0"/>
-              <a:t>2026/08/18</a:t>
+              <a:t>2026/08/25</a:t>
             </a:fld>
             <a:endParaRPr lang="en-ZA"/>
           </a:p>
@@ -1237,7 +1240,7 @@
           <a:p>
             <a:fld id="{B31332A8-CEAE-4241-9842-981792316C5A}" type="datetimeFigureOut">
               <a:rPr lang="en-ZA" smtClean="0"/>
-              <a:t>2026/08/18</a:t>
+              <a:t>2026/08/25</a:t>
             </a:fld>
             <a:endParaRPr lang="en-ZA"/>
           </a:p>
@@ -1505,7 +1508,7 @@
           <a:p>
             <a:fld id="{B31332A8-CEAE-4241-9842-981792316C5A}" type="datetimeFigureOut">
               <a:rPr lang="en-ZA" smtClean="0"/>
-              <a:t>2026/08/18</a:t>
+              <a:t>2026/08/25</a:t>
             </a:fld>
             <a:endParaRPr lang="en-ZA"/>
           </a:p>
@@ -1920,7 +1923,7 @@
           <a:p>
             <a:fld id="{B31332A8-CEAE-4241-9842-981792316C5A}" type="datetimeFigureOut">
               <a:rPr lang="en-ZA" smtClean="0"/>
-              <a:t>2026/08/18</a:t>
+              <a:t>2026/08/25</a:t>
             </a:fld>
             <a:endParaRPr lang="en-ZA"/>
           </a:p>
@@ -2062,7 +2065,7 @@
           <a:p>
             <a:fld id="{B31332A8-CEAE-4241-9842-981792316C5A}" type="datetimeFigureOut">
               <a:rPr lang="en-ZA" smtClean="0"/>
-              <a:t>2026/08/18</a:t>
+              <a:t>2026/08/25</a:t>
             </a:fld>
             <a:endParaRPr lang="en-ZA"/>
           </a:p>
@@ -2175,7 +2178,7 @@
           <a:p>
             <a:fld id="{B31332A8-CEAE-4241-9842-981792316C5A}" type="datetimeFigureOut">
               <a:rPr lang="en-ZA" smtClean="0"/>
-              <a:t>2026/08/18</a:t>
+              <a:t>2026/08/25</a:t>
             </a:fld>
             <a:endParaRPr lang="en-ZA"/>
           </a:p>
@@ -2488,7 +2491,7 @@
           <a:p>
             <a:fld id="{B31332A8-CEAE-4241-9842-981792316C5A}" type="datetimeFigureOut">
               <a:rPr lang="en-ZA" smtClean="0"/>
-              <a:t>2026/08/18</a:t>
+              <a:t>2026/08/25</a:t>
             </a:fld>
             <a:endParaRPr lang="en-ZA"/>
           </a:p>
@@ -2777,7 +2780,7 @@
           <a:p>
             <a:fld id="{B31332A8-CEAE-4241-9842-981792316C5A}" type="datetimeFigureOut">
               <a:rPr lang="en-ZA" smtClean="0"/>
-              <a:t>2026/08/18</a:t>
+              <a:t>2026/08/25</a:t>
             </a:fld>
             <a:endParaRPr lang="en-ZA"/>
           </a:p>
@@ -3020,7 +3023,7 @@
           <a:p>
             <a:fld id="{B31332A8-CEAE-4241-9842-981792316C5A}" type="datetimeFigureOut">
               <a:rPr lang="en-ZA" smtClean="0"/>
-              <a:t>2026/08/18</a:t>
+              <a:t>2026/08/25</a:t>
             </a:fld>
             <a:endParaRPr lang="en-ZA"/>
           </a:p>
@@ -3488,7 +3491,7 @@
                   <a:srgbClr val="C00000"/>
                 </a:solidFill>
               </a:rPr>
-              <a:t>Term 3 Week 5 – Progress Meeting</a:t>
+              <a:t>Term 3 Week 6 – Progress Meeting</a:t>
             </a:r>
             <a:endParaRPr lang="en-ZA" sz="4000" dirty="0">
               <a:solidFill>
@@ -3513,7 +3516,7 @@
         <p:spPr>
           <a:xfrm>
             <a:off x="1080977" y="1637414"/>
-            <a:ext cx="10037135" cy="1631216"/>
+            <a:ext cx="10037135" cy="1015663"/>
           </a:xfrm>
           <a:prstGeom prst="rect">
             <a:avLst/>
@@ -3544,27 +3547,7 @@
             </a:pPr>
             <a:r>
               <a:rPr lang="en-US" sz="2000" dirty="0"/>
-              <a:t>Report feedback</a:t>
-            </a:r>
-          </a:p>
-          <a:p>
-            <a:pPr marL="342900" indent="-342900">
-              <a:buFont typeface="Arial" panose="020B0604020202020204" pitchFamily="34" charset="0"/>
-              <a:buChar char="•"/>
-            </a:pPr>
-            <a:r>
-              <a:rPr lang="en-US" sz="2000" dirty="0"/>
-              <a:t>Drawings hand-in</a:t>
-            </a:r>
-          </a:p>
-          <a:p>
-            <a:pPr marL="342900" indent="-342900">
-              <a:buFont typeface="Arial" panose="020B0604020202020204" pitchFamily="34" charset="0"/>
-              <a:buChar char="•"/>
-            </a:pPr>
-            <a:r>
-              <a:rPr lang="en-US" sz="2000" dirty="0"/>
-              <a:t>Safety report</a:t>
+              <a:t>Report updating</a:t>
             </a:r>
           </a:p>
           <a:p>
@@ -3736,7 +3719,7 @@
                   <a:schemeClr val="tx1"/>
                 </a:solidFill>
               </a:rPr>
-              <a:t>Going through final report feedback and up dating</a:t>
+              <a:t>Introduction updated – Joint focused</a:t>
             </a:r>
           </a:p>
           <a:p>
@@ -3750,7 +3733,7 @@
                   <a:schemeClr val="tx1"/>
                 </a:solidFill>
               </a:rPr>
-              <a:t>Drawings were handed in to the workshop last week Wednesday</a:t>
+              <a:t>Literature review in the process of being updated</a:t>
             </a:r>
           </a:p>
           <a:p>
@@ -3764,56 +3747,242 @@
                   <a:schemeClr val="tx1"/>
                 </a:solidFill>
               </a:rPr>
-              <a:t>RS components have been received, </a:t>
-            </a:r>
-            <a:r>
-              <a:rPr lang="en-US" dirty="0" err="1">
+              <a:t>Safety report still being written</a:t>
+            </a:r>
+          </a:p>
+          <a:p>
+            <a:pPr marL="285750" indent="-285750">
+              <a:buFont typeface="Arial" panose="020B0604020202020204" pitchFamily="34" charset="0"/>
+              <a:buChar char="•"/>
+            </a:pPr>
+            <a:r>
+              <a:rPr lang="en-ZA" dirty="0">
                 <a:solidFill>
                   <a:schemeClr val="tx1"/>
                 </a:solidFill>
               </a:rPr>
-              <a:t>MicroRobotics</a:t>
-            </a:r>
+              <a:t>Software development has begun</a:t>
+            </a:r>
+          </a:p>
+          <a:p>
+            <a:pPr marL="742950" lvl="1" indent="-285750">
+              <a:buFont typeface="Arial" panose="020B0604020202020204" pitchFamily="34" charset="0"/>
+              <a:buChar char="•"/>
+            </a:pPr>
+            <a:r>
+              <a:rPr lang="en-ZA" dirty="0">
+                <a:solidFill>
+                  <a:schemeClr val="tx1"/>
+                </a:solidFill>
+              </a:rPr>
+              <a:t>Testing a few electrical components</a:t>
+            </a:r>
+          </a:p>
+          <a:p>
+            <a:pPr marL="742950" lvl="1" indent="-285750">
+              <a:buFont typeface="Arial" panose="020B0604020202020204" pitchFamily="34" charset="0"/>
+              <a:buChar char="•"/>
+            </a:pPr>
+            <a:r>
+              <a:rPr lang="en-ZA" dirty="0">
+                <a:solidFill>
+                  <a:schemeClr val="tx1"/>
+                </a:solidFill>
+              </a:rPr>
+              <a:t>Deriving control signal for electromagnet</a:t>
+            </a:r>
+          </a:p>
+          <a:p>
+            <a:pPr marL="742950" lvl="1" indent="-285750">
+              <a:buFont typeface="Arial" panose="020B0604020202020204" pitchFamily="34" charset="0"/>
+              <a:buChar char="•"/>
+            </a:pPr>
+            <a:r>
+              <a:rPr lang="en-ZA" dirty="0">
+                <a:solidFill>
+                  <a:schemeClr val="tx1"/>
+                </a:solidFill>
+              </a:rPr>
+              <a:t>Documenting experiment report</a:t>
+            </a:r>
+          </a:p>
+        </p:txBody>
+      </p:sp>
+    </p:spTree>
+    <p:extLst>
+      <p:ext uri="{BB962C8B-B14F-4D97-AF65-F5344CB8AC3E}">
+        <p14:creationId xmlns:p14="http://schemas.microsoft.com/office/powerpoint/2010/main" val="1867381965"/>
+      </p:ext>
+    </p:extLst>
+  </p:cSld>
+  <p:clrMapOvr>
+    <a:masterClrMapping/>
+  </p:clrMapOvr>
+</p:sld>
+</file>
+
+<file path=ppt/slides/slide3.xml><?xml version="1.0" encoding="utf-8"?>
+<p:sld xmlns:a="http://schemas.openxmlformats.org/drawingml/2006/main" xmlns:r="http://schemas.openxmlformats.org/officeDocument/2006/relationships" xmlns:p="http://schemas.openxmlformats.org/presentationml/2006/main">
+  <p:cSld>
+    <p:bg>
+      <p:bgPr>
+        <a:blipFill dpi="0" rotWithShape="1">
+          <a:blip r:embed="rId2">
+            <a:lum/>
+          </a:blip>
+          <a:srcRect/>
+          <a:stretch>
+            <a:fillRect/>
+          </a:stretch>
+        </a:blipFill>
+        <a:effectLst/>
+      </p:bgPr>
+    </p:bg>
+    <p:spTree>
+      <p:nvGrpSpPr>
+        <p:cNvPr id="1" name="">
+          <a:extLst>
+            <a:ext uri="{FF2B5EF4-FFF2-40B4-BE49-F238E27FC236}">
+              <a16:creationId xmlns:a16="http://schemas.microsoft.com/office/drawing/2014/main" id="{17C5A1AE-02A7-1ED8-1F62-C23B21D49BD9}"/>
+            </a:ext>
+          </a:extLst>
+        </p:cNvPr>
+        <p:cNvGrpSpPr/>
+        <p:nvPr/>
+      </p:nvGrpSpPr>
+      <p:grpSpPr>
+        <a:xfrm>
+          <a:off x="0" y="0"/>
+          <a:ext cx="0" cy="0"/>
+          <a:chOff x="0" y="0"/>
+          <a:chExt cx="0" cy="0"/>
+        </a:xfrm>
+      </p:grpSpPr>
+      <p:sp>
+        <p:nvSpPr>
+          <p:cNvPr id="2" name="TextBox 1">
+            <a:extLst>
+              <a:ext uri="{FF2B5EF4-FFF2-40B4-BE49-F238E27FC236}">
+                <a16:creationId xmlns:a16="http://schemas.microsoft.com/office/drawing/2014/main" id="{FC705E6B-6953-9B97-463A-66E335DE2B38}"/>
+              </a:ext>
+            </a:extLst>
+          </p:cNvPr>
+          <p:cNvSpPr txBox="1"/>
+          <p:nvPr/>
+        </p:nvSpPr>
+        <p:spPr>
+          <a:xfrm>
+            <a:off x="2321442" y="499731"/>
+            <a:ext cx="7549116" cy="707886"/>
+          </a:xfrm>
+          <a:prstGeom prst="rect">
+            <a:avLst/>
+          </a:prstGeom>
+          <a:solidFill>
+            <a:schemeClr val="bg1"/>
+          </a:solidFill>
+        </p:spPr>
+        <p:txBody>
+          <a:bodyPr wrap="square" rtlCol="0">
+            <a:spAutoFit/>
+          </a:bodyPr>
+          <a:lstStyle/>
+          <a:p>
+            <a:pPr algn="ctr"/>
+            <a:r>
+              <a:rPr lang="en-US" sz="4000" dirty="0">
+                <a:solidFill>
+                  <a:srgbClr val="C00000"/>
+                </a:solidFill>
+              </a:rPr>
+              <a:t>Q&amp;A</a:t>
+            </a:r>
+            <a:endParaRPr lang="en-ZA" sz="4000" dirty="0">
+              <a:solidFill>
+                <a:srgbClr val="C00000"/>
+              </a:solidFill>
+            </a:endParaRPr>
+          </a:p>
+        </p:txBody>
+      </p:sp>
+      <p:sp>
+        <p:nvSpPr>
+          <p:cNvPr id="3" name="Rectangle 2">
+            <a:extLst>
+              <a:ext uri="{FF2B5EF4-FFF2-40B4-BE49-F238E27FC236}">
+                <a16:creationId xmlns:a16="http://schemas.microsoft.com/office/drawing/2014/main" id="{6EB54202-9793-E8F1-B053-6A5BEF0A4839}"/>
+              </a:ext>
+            </a:extLst>
+          </p:cNvPr>
+          <p:cNvSpPr/>
+          <p:nvPr/>
+        </p:nvSpPr>
+        <p:spPr>
+          <a:xfrm>
+            <a:off x="1194390" y="2239540"/>
+            <a:ext cx="9803219" cy="2378920"/>
+          </a:xfrm>
+          <a:prstGeom prst="rect">
+            <a:avLst/>
+          </a:prstGeom>
+          <a:solidFill>
+            <a:schemeClr val="bg1"/>
+          </a:solidFill>
+          <a:ln>
+            <a:solidFill>
+              <a:schemeClr val="bg1"/>
+            </a:solidFill>
+          </a:ln>
+        </p:spPr>
+        <p:style>
+          <a:lnRef idx="2">
+            <a:schemeClr val="accent1">
+              <a:shade val="15000"/>
+            </a:schemeClr>
+          </a:lnRef>
+          <a:fillRef idx="1">
+            <a:schemeClr val="accent1"/>
+          </a:fillRef>
+          <a:effectRef idx="0">
+            <a:schemeClr val="accent1"/>
+          </a:effectRef>
+          <a:fontRef idx="minor">
+            <a:schemeClr val="lt1"/>
+          </a:fontRef>
+        </p:style>
+        <p:txBody>
+          <a:bodyPr rtlCol="0" anchor="ctr"/>
+          <a:lstStyle/>
+          <a:p>
+            <a:pPr marL="285750" indent="-285750">
+              <a:buFont typeface="Arial" panose="020B0604020202020204" pitchFamily="34" charset="0"/>
+              <a:buChar char="•"/>
+            </a:pPr>
             <a:r>
               <a:rPr lang="en-US" dirty="0">
                 <a:solidFill>
                   <a:schemeClr val="tx1"/>
                 </a:solidFill>
               </a:rPr>
-              <a:t> </a:t>
-            </a:r>
-            <a:r>
-              <a:rPr lang="en-US" dirty="0" err="1">
-                <a:solidFill>
-                  <a:schemeClr val="tx1"/>
-                </a:solidFill>
-              </a:rPr>
-              <a:t>componented</a:t>
-            </a:r>
+              <a:t>Can extra documentation be included in the appendix?</a:t>
+            </a:r>
+          </a:p>
+          <a:p>
+            <a:pPr marL="742950" lvl="1" indent="-285750">
+              <a:buFont typeface="Arial" panose="020B0604020202020204" pitchFamily="34" charset="0"/>
+              <a:buChar char="•"/>
+            </a:pPr>
             <a:r>
               <a:rPr lang="en-US" dirty="0">
                 <a:solidFill>
                   <a:schemeClr val="tx1"/>
                 </a:solidFill>
               </a:rPr>
-              <a:t> to be collected at </a:t>
-            </a:r>
-            <a:r>
-              <a:rPr lang="en-US" dirty="0" err="1">
-                <a:solidFill>
-                  <a:schemeClr val="tx1"/>
-                </a:solidFill>
-              </a:rPr>
-              <a:t>TechnoPark</a:t>
-            </a:r>
-            <a:endParaRPr lang="en-US" dirty="0">
-              <a:solidFill>
-                <a:schemeClr val="tx1"/>
-              </a:solidFill>
-            </a:endParaRPr>
-          </a:p>
-          <a:p>
-            <a:pPr marL="285750" indent="-285750">
+              <a:t>Drawing pack</a:t>
+            </a:r>
+          </a:p>
+          <a:p>
+            <a:pPr marL="742950" lvl="1" indent="-285750">
               <a:buFont typeface="Arial" panose="020B0604020202020204" pitchFamily="34" charset="0"/>
               <a:buChar char="•"/>
             </a:pPr>
@@ -3823,21 +3992,22 @@
                   <a:schemeClr val="tx1"/>
                 </a:solidFill>
               </a:rPr>
-              <a:t>Started safety report, will contact and consult with Prof. Blaine for </a:t>
-            </a:r>
-            <a:r>
-              <a:rPr lang="en-US">
+              <a:t>Safety report</a:t>
+            </a:r>
+          </a:p>
+          <a:p>
+            <a:pPr marL="742950" lvl="1" indent="-285750">
+              <a:buFont typeface="Arial" panose="020B0604020202020204" pitchFamily="34" charset="0"/>
+              <a:buChar char="•"/>
+            </a:pPr>
+            <a:r>
+              <a:rPr lang="en-US" dirty="0">
                 <a:solidFill>
                   <a:schemeClr val="tx1"/>
                 </a:solidFill>
               </a:rPr>
-              <a:t>strain gauges</a:t>
-            </a:r>
-            <a:endParaRPr lang="en-US" dirty="0">
-              <a:solidFill>
-                <a:schemeClr val="tx1"/>
-              </a:solidFill>
-            </a:endParaRPr>
+              <a:t>Experimental report</a:t>
+            </a:r>
           </a:p>
           <a:p>
             <a:pPr marL="285750" indent="-285750">
@@ -3845,12 +4015,12 @@
               <a:buChar char="•"/>
             </a:pPr>
             <a:r>
-              <a:rPr lang="en-ZA" dirty="0">
+              <a:rPr lang="en-US" dirty="0">
                 <a:solidFill>
                   <a:schemeClr val="tx1"/>
                 </a:solidFill>
               </a:rPr>
-              <a:t>Software development will begin this weekend</a:t>
+              <a:t>Or this is what the portfolio is for?</a:t>
             </a:r>
           </a:p>
         </p:txBody>
@@ -3858,7 +4028,7 @@
     </p:spTree>
     <p:extLst>
       <p:ext uri="{BB962C8B-B14F-4D97-AF65-F5344CB8AC3E}">
-        <p14:creationId xmlns:p14="http://schemas.microsoft.com/office/powerpoint/2010/main" val="1867381965"/>
+        <p14:creationId xmlns:p14="http://schemas.microsoft.com/office/powerpoint/2010/main" val="321170222"/>
       </p:ext>
     </p:extLst>
   </p:cSld>

</xml_diff>